<commit_message>
docs: スライド4のOSV表記に正式名称(Open Source Vulnerabilities)を追記
スライド本文とスピーカーノートの両方に「OSV = Open Source Vulnerabilities」を追加。
pptxgenjs skillのvalidate.pyで検証済み、テキストのはみ出しなし。

Co-Authored-By: Claude Sonnet 5 <noreply@anthropic.com>
Claude-Session: https://claude.ai/code/session_017PiiPbfWPjiaquesxgPQkR
</commit_message>
<xml_diff>
--- a/docs/ai-built-tools-process.pptx
+++ b/docs/ai-built-tools-process.pptx
@@ -1489,7 +1489,7 @@
           <a:p>
             <a:r>
               <a:rPr lang="en-US" dirty="0"/>
-              <a:t>クラウドからは OSV や GitHub の API に届きません。そこで、モックで確かめたあと、PC か Actions で実通信を確かめる 2 段構えにしました。</a:t>
+              <a:t>OSV = Open Source Vulnerabilities(osv.dev、Googleが運営するOSSの脆弱性データベース)。クラウドからは OSV や GitHub の API に届きません。そこで、モックで確かめたあと、PC か Actions で実通信を確かめる 2 段構えにしました。</a:t>
             </a:r>
             <a:endParaRPr lang="en-US" dirty="0"/>
           </a:p>
@@ -7401,7 +7401,7 @@
                 <a:ea typeface="Yu Gothic" pitchFamily="34" charset="-122"/>
                 <a:cs typeface="Yu Gothic" pitchFamily="34" charset="-120"/>
               </a:rPr>
-              <a:t>実通信(OSV、GitHub)、Ollama</a:t>
+              <a:t>実通信(OSV=Open Source Vulnerabilities、GitHub)、Ollama</a:t>
             </a:r>
             <a:endParaRPr lang="en-US" sz="1400" dirty="0"/>
           </a:p>

</xml_diff>